<commit_message>
style: increase body text font sizes for better readability
</commit_message>
<xml_diff>
--- a/AirSeva_1M1B_Submission_Redesigned.pptx
+++ b/AirSeva_1M1B_Submission_Redesigned.pptx
@@ -3210,7 +3210,7 @@
               </a:spcAft>
             </a:pPr>
             <a:r>
-              <a:rPr sz="1400" b="0" i="0">
+              <a:rPr sz="1500" b="0" i="0">
                 <a:solidFill>
                   <a:srgbClr val="646464"/>
                 </a:solidFill>
@@ -3226,7 +3226,7 @@
               </a:spcAft>
             </a:pPr>
             <a:r>
-              <a:rPr sz="1400" b="0" i="0">
+              <a:rPr sz="1500" b="0" i="0">
                 <a:solidFill>
                   <a:srgbClr val="646464"/>
                 </a:solidFill>
@@ -3242,7 +3242,7 @@
               </a:spcAft>
             </a:pPr>
             <a:r>
-              <a:rPr sz="1400" b="0" i="0">
+              <a:rPr sz="1500" b="0" i="0">
                 <a:solidFill>
                   <a:srgbClr val="646464"/>
                 </a:solidFill>
@@ -3298,7 +3298,7 @@
               </a:spcAft>
             </a:pPr>
             <a:r>
-              <a:rPr sz="1200" b="0" i="0">
+              <a:rPr sz="1300" b="0" i="0">
                 <a:solidFill>
                   <a:srgbClr val="0F2850"/>
                 </a:solidFill>
@@ -3542,7 +3542,7 @@
               </a:spcAft>
             </a:pPr>
             <a:r>
-              <a:rPr sz="1300" b="0" i="0">
+              <a:rPr sz="1500" b="0" i="0">
                 <a:solidFill>
                   <a:srgbClr val="323232"/>
                 </a:solidFill>
@@ -3630,7 +3630,7 @@
               </a:spcAft>
             </a:pPr>
             <a:r>
-              <a:rPr sz="1300" b="0" i="0">
+              <a:rPr sz="1500" b="0" i="0">
                 <a:solidFill>
                   <a:srgbClr val="323232"/>
                 </a:solidFill>
@@ -3842,7 +3842,7 @@
               </a:spcAft>
             </a:pPr>
             <a:r>
-              <a:rPr sz="1400" b="0" i="1">
+              <a:rPr sz="1600" b="0" i="1">
                 <a:solidFill>
                   <a:srgbClr val="323232"/>
                 </a:solidFill>
@@ -3930,7 +3930,7 @@
               </a:spcAft>
             </a:pPr>
             <a:r>
-              <a:rPr sz="1300" b="0" i="0">
+              <a:rPr sz="1500" b="0" i="0">
                 <a:solidFill>
                   <a:srgbClr val="323232"/>
                 </a:solidFill>
@@ -3946,7 +3946,7 @@
               </a:spcAft>
             </a:pPr>
             <a:r>
-              <a:rPr sz="1300" b="0" i="0">
+              <a:rPr sz="1500" b="0" i="0">
                 <a:solidFill>
                   <a:srgbClr val="323232"/>
                 </a:solidFill>
@@ -4034,7 +4034,7 @@
               </a:spcAft>
             </a:pPr>
             <a:r>
-              <a:rPr sz="1300" b="0" i="0">
+              <a:rPr sz="1500" b="0" i="0">
                 <a:solidFill>
                   <a:srgbClr val="323232"/>
                 </a:solidFill>
@@ -4122,7 +4122,7 @@
               </a:spcAft>
             </a:pPr>
             <a:r>
-              <a:rPr sz="1300" b="0" i="0">
+              <a:rPr sz="1500" b="0" i="0">
                 <a:solidFill>
                   <a:srgbClr val="323232"/>
                 </a:solidFill>
@@ -4366,7 +4366,7 @@
               </a:spcAft>
             </a:pPr>
             <a:r>
-              <a:rPr sz="1100" b="0" i="0">
+              <a:rPr sz="1300" b="0" i="0">
                 <a:solidFill>
                   <a:srgbClr val="323232"/>
                 </a:solidFill>
@@ -4382,7 +4382,7 @@
               </a:spcAft>
             </a:pPr>
             <a:r>
-              <a:rPr sz="1100" b="0" i="0">
+              <a:rPr sz="1300" b="0" i="0">
                 <a:solidFill>
                   <a:srgbClr val="323232"/>
                 </a:solidFill>
@@ -4398,7 +4398,7 @@
               </a:spcAft>
             </a:pPr>
             <a:r>
-              <a:rPr sz="1100" b="0" i="0">
+              <a:rPr sz="1300" b="0" i="0">
                 <a:solidFill>
                   <a:srgbClr val="323232"/>
                 </a:solidFill>
@@ -4486,7 +4486,7 @@
               </a:spcAft>
             </a:pPr>
             <a:r>
-              <a:rPr sz="1100" b="0" i="0">
+              <a:rPr sz="1300" b="0" i="0">
                 <a:solidFill>
                   <a:srgbClr val="323232"/>
                 </a:solidFill>
@@ -4502,7 +4502,7 @@
               </a:spcAft>
             </a:pPr>
             <a:r>
-              <a:rPr sz="1100" b="0" i="0">
+              <a:rPr sz="1300" b="0" i="0">
                 <a:solidFill>
                   <a:srgbClr val="323232"/>
                 </a:solidFill>
@@ -4518,7 +4518,7 @@
               </a:spcAft>
             </a:pPr>
             <a:r>
-              <a:rPr sz="1100" b="0" i="0">
+              <a:rPr sz="1300" b="0" i="0">
                 <a:solidFill>
                   <a:srgbClr val="323232"/>
                 </a:solidFill>
@@ -4606,7 +4606,7 @@
               </a:spcAft>
             </a:pPr>
             <a:r>
-              <a:rPr sz="1100" b="0" i="0">
+              <a:rPr sz="1300" b="0" i="0">
                 <a:solidFill>
                   <a:srgbClr val="323232"/>
                 </a:solidFill>
@@ -4622,7 +4622,7 @@
               </a:spcAft>
             </a:pPr>
             <a:r>
-              <a:rPr sz="1100" b="0" i="0">
+              <a:rPr sz="1300" b="0" i="0">
                 <a:solidFill>
                   <a:srgbClr val="323232"/>
                 </a:solidFill>
@@ -4638,7 +4638,7 @@
               </a:spcAft>
             </a:pPr>
             <a:r>
-              <a:rPr sz="1100" b="0" i="0">
+              <a:rPr sz="1300" b="0" i="0">
                 <a:solidFill>
                   <a:srgbClr val="323232"/>
                 </a:solidFill>
@@ -4726,7 +4726,7 @@
               </a:spcAft>
             </a:pPr>
             <a:r>
-              <a:rPr sz="1100" b="0" i="0">
+              <a:rPr sz="1300" b="0" i="0">
                 <a:solidFill>
                   <a:srgbClr val="323232"/>
                 </a:solidFill>
@@ -4742,7 +4742,7 @@
               </a:spcAft>
             </a:pPr>
             <a:r>
-              <a:rPr sz="1100" b="0" i="0">
+              <a:rPr sz="1300" b="0" i="0">
                 <a:solidFill>
                   <a:srgbClr val="323232"/>
                 </a:solidFill>
@@ -4758,7 +4758,7 @@
               </a:spcAft>
             </a:pPr>
             <a:r>
-              <a:rPr sz="1100" b="0" i="0">
+              <a:rPr sz="1300" b="0" i="0">
                 <a:solidFill>
                   <a:srgbClr val="323232"/>
                 </a:solidFill>
@@ -4846,7 +4846,7 @@
               </a:spcAft>
             </a:pPr>
             <a:r>
-              <a:rPr sz="1100" b="0" i="0">
+              <a:rPr sz="1300" b="0" i="0">
                 <a:solidFill>
                   <a:srgbClr val="323232"/>
                 </a:solidFill>
@@ -4862,7 +4862,7 @@
               </a:spcAft>
             </a:pPr>
             <a:r>
-              <a:rPr sz="1100" b="0" i="0">
+              <a:rPr sz="1300" b="0" i="0">
                 <a:solidFill>
                   <a:srgbClr val="323232"/>
                 </a:solidFill>
@@ -4878,7 +4878,7 @@
               </a:spcAft>
             </a:pPr>
             <a:r>
-              <a:rPr sz="1100" b="0" i="0">
+              <a:rPr sz="1300" b="0" i="0">
                 <a:solidFill>
                   <a:srgbClr val="323232"/>
                 </a:solidFill>
@@ -5089,7 +5089,7 @@
               </a:spcAft>
             </a:pPr>
             <a:r>
-              <a:rPr sz="1100" b="0" i="0">
+              <a:rPr sz="1200" b="0" i="0">
                 <a:solidFill>
                   <a:srgbClr val="646464"/>
                 </a:solidFill>
@@ -5333,7 +5333,7 @@
               </a:spcAft>
             </a:pPr>
             <a:r>
-              <a:rPr sz="1300" b="0" i="0">
+              <a:rPr sz="1500" b="0" i="0">
                 <a:solidFill>
                   <a:srgbClr val="323232"/>
                 </a:solidFill>
@@ -5421,7 +5421,7 @@
               </a:spcAft>
             </a:pPr>
             <a:r>
-              <a:rPr sz="1300" b="0" i="0">
+              <a:rPr sz="1500" b="0" i="0">
                 <a:solidFill>
                   <a:srgbClr val="323232"/>
                 </a:solidFill>
@@ -5509,7 +5509,7 @@
               </a:spcAft>
             </a:pPr>
             <a:r>
-              <a:rPr sz="1300" b="0" i="0">
+              <a:rPr sz="1500" b="0" i="0">
                 <a:solidFill>
                   <a:srgbClr val="323232"/>
                 </a:solidFill>
@@ -5597,7 +5597,7 @@
               </a:spcAft>
             </a:pPr>
             <a:r>
-              <a:rPr sz="1300" b="0" i="0">
+              <a:rPr sz="1500" b="0" i="0">
                 <a:solidFill>
                   <a:srgbClr val="323232"/>
                 </a:solidFill>
@@ -5841,7 +5841,7 @@
               </a:spcAft>
             </a:pPr>
             <a:r>
-              <a:rPr sz="1300" b="0" i="0">
+              <a:rPr sz="1500" b="0" i="0">
                 <a:solidFill>
                   <a:srgbClr val="323232"/>
                 </a:solidFill>
@@ -5929,7 +5929,7 @@
               </a:spcAft>
             </a:pPr>
             <a:r>
-              <a:rPr sz="1300" b="0" i="0">
+              <a:rPr sz="1500" b="0" i="0">
                 <a:solidFill>
                   <a:srgbClr val="323232"/>
                 </a:solidFill>
@@ -6017,7 +6017,7 @@
               </a:spcAft>
             </a:pPr>
             <a:r>
-              <a:rPr sz="1300" b="0" i="0">
+              <a:rPr sz="1500" b="0" i="0">
                 <a:solidFill>
                   <a:srgbClr val="323232"/>
                 </a:solidFill>
@@ -6105,7 +6105,7 @@
               </a:spcAft>
             </a:pPr>
             <a:r>
-              <a:rPr sz="1300" b="0" i="0">
+              <a:rPr sz="1500" b="0" i="0">
                 <a:solidFill>
                   <a:srgbClr val="323232"/>
                 </a:solidFill>
@@ -6349,7 +6349,7 @@
               </a:spcAft>
             </a:pPr>
             <a:r>
-              <a:rPr sz="1300" b="0" i="0">
+              <a:rPr sz="1500" b="0" i="0">
                 <a:solidFill>
                   <a:srgbClr val="323232"/>
                 </a:solidFill>
@@ -6365,7 +6365,7 @@
               </a:spcAft>
             </a:pPr>
             <a:r>
-              <a:rPr sz="1300" b="0" i="0">
+              <a:rPr sz="1500" b="0" i="0">
                 <a:solidFill>
                   <a:srgbClr val="323232"/>
                 </a:solidFill>
@@ -6381,7 +6381,7 @@
               </a:spcAft>
             </a:pPr>
             <a:r>
-              <a:rPr sz="1300" b="0" i="0">
+              <a:rPr sz="1500" b="0" i="0">
                 <a:solidFill>
                   <a:srgbClr val="323232"/>
                 </a:solidFill>
@@ -6469,7 +6469,7 @@
               </a:spcAft>
             </a:pPr>
             <a:r>
-              <a:rPr sz="1300" b="0" i="0">
+              <a:rPr sz="1500" b="0" i="0">
                 <a:solidFill>
                   <a:srgbClr val="323232"/>
                 </a:solidFill>
@@ -6485,7 +6485,7 @@
               </a:spcAft>
             </a:pPr>
             <a:r>
-              <a:rPr sz="1300" b="0" i="0">
+              <a:rPr sz="1500" b="0" i="0">
                 <a:solidFill>
                   <a:srgbClr val="323232"/>
                 </a:solidFill>
@@ -6501,7 +6501,7 @@
               </a:spcAft>
             </a:pPr>
             <a:r>
-              <a:rPr sz="1300" b="0" i="0">
+              <a:rPr sz="1500" b="0" i="0">
                 <a:solidFill>
                   <a:srgbClr val="323232"/>
                 </a:solidFill>
@@ -6589,7 +6589,7 @@
               </a:spcAft>
             </a:pPr>
             <a:r>
-              <a:rPr sz="1300" b="0" i="0">
+              <a:rPr sz="1500" b="0" i="0">
                 <a:solidFill>
                   <a:srgbClr val="323232"/>
                 </a:solidFill>
@@ -6605,7 +6605,7 @@
               </a:spcAft>
             </a:pPr>
             <a:r>
-              <a:rPr sz="1300" b="0" i="0">
+              <a:rPr sz="1500" b="0" i="0">
                 <a:solidFill>
                   <a:srgbClr val="323232"/>
                 </a:solidFill>
@@ -6621,7 +6621,7 @@
               </a:spcAft>
             </a:pPr>
             <a:r>
-              <a:rPr sz="1300" b="0" i="0">
+              <a:rPr sz="1500" b="0" i="0">
                 <a:solidFill>
                   <a:srgbClr val="323232"/>
                 </a:solidFill>
@@ -6660,7 +6660,7 @@
               </a:spcAft>
             </a:pPr>
             <a:r>
-              <a:rPr sz="1200" b="0" i="1">
+              <a:rPr sz="1300" b="0" i="1">
                 <a:solidFill>
                   <a:srgbClr val="646464"/>
                 </a:solidFill>
@@ -6904,7 +6904,7 @@
               </a:spcAft>
             </a:pPr>
             <a:r>
-              <a:rPr sz="1200" b="0" i="0">
+              <a:rPr sz="1400" b="0" i="0">
                 <a:solidFill>
                   <a:srgbClr val="323232"/>
                 </a:solidFill>
@@ -6920,7 +6920,7 @@
               </a:spcAft>
             </a:pPr>
             <a:r>
-              <a:rPr sz="1200" b="0" i="0">
+              <a:rPr sz="1400" b="0" i="0">
                 <a:solidFill>
                   <a:srgbClr val="323232"/>
                 </a:solidFill>
@@ -6936,7 +6936,7 @@
               </a:spcAft>
             </a:pPr>
             <a:r>
-              <a:rPr sz="1200" b="0" i="0">
+              <a:rPr sz="1400" b="0" i="0">
                 <a:solidFill>
                   <a:srgbClr val="323232"/>
                 </a:solidFill>
@@ -6952,7 +6952,7 @@
               </a:spcAft>
             </a:pPr>
             <a:r>
-              <a:rPr sz="1200" b="0" i="0">
+              <a:rPr sz="1400" b="0" i="0">
                 <a:solidFill>
                   <a:srgbClr val="323232"/>
                 </a:solidFill>
@@ -6968,7 +6968,7 @@
               </a:spcAft>
             </a:pPr>
             <a:r>
-              <a:rPr sz="1200" b="0" i="0">
+              <a:rPr sz="1400" b="0" i="0">
                 <a:solidFill>
                   <a:srgbClr val="323232"/>
                 </a:solidFill>
@@ -6984,7 +6984,7 @@
               </a:spcAft>
             </a:pPr>
             <a:r>
-              <a:rPr sz="1200" b="0" i="0">
+              <a:rPr sz="1400" b="0" i="0">
                 <a:solidFill>
                   <a:srgbClr val="323232"/>
                 </a:solidFill>
@@ -7072,7 +7072,7 @@
               </a:spcAft>
             </a:pPr>
             <a:r>
-              <a:rPr sz="1200" b="0" i="0">
+              <a:rPr sz="1400" b="0" i="0">
                 <a:solidFill>
                   <a:srgbClr val="323232"/>
                 </a:solidFill>
@@ -7088,7 +7088,7 @@
               </a:spcAft>
             </a:pPr>
             <a:r>
-              <a:rPr sz="1200" b="0" i="0">
+              <a:rPr sz="1400" b="0" i="0">
                 <a:solidFill>
                   <a:srgbClr val="323232"/>
                 </a:solidFill>
@@ -7104,7 +7104,7 @@
               </a:spcAft>
             </a:pPr>
             <a:r>
-              <a:rPr sz="1200" b="0" i="0">
+              <a:rPr sz="1400" b="0" i="0">
                 <a:solidFill>
                   <a:srgbClr val="323232"/>
                 </a:solidFill>
@@ -7120,7 +7120,7 @@
               </a:spcAft>
             </a:pPr>
             <a:r>
-              <a:rPr sz="1200" b="0" i="0">
+              <a:rPr sz="1400" b="0" i="0">
                 <a:solidFill>
                   <a:srgbClr val="323232"/>
                 </a:solidFill>
@@ -7136,7 +7136,7 @@
               </a:spcAft>
             </a:pPr>
             <a:r>
-              <a:rPr sz="1200" b="0" i="0">
+              <a:rPr sz="1400" b="0" i="0">
                 <a:solidFill>
                   <a:srgbClr val="323232"/>
                 </a:solidFill>
@@ -7152,7 +7152,7 @@
               </a:spcAft>
             </a:pPr>
             <a:r>
-              <a:rPr sz="1200" b="0" i="0">
+              <a:rPr sz="1400" b="0" i="0">
                 <a:solidFill>
                   <a:srgbClr val="323232"/>
                 </a:solidFill>
@@ -7168,7 +7168,7 @@
               </a:spcAft>
             </a:pPr>
             <a:r>
-              <a:rPr sz="1200" b="0" i="0">
+              <a:rPr sz="1400" b="0" i="0">
                 <a:solidFill>
                   <a:srgbClr val="323232"/>
                 </a:solidFill>
@@ -7184,7 +7184,7 @@
               </a:spcAft>
             </a:pPr>
             <a:r>
-              <a:rPr sz="1200" b="0" i="0">
+              <a:rPr sz="1400" b="0" i="0">
                 <a:solidFill>
                   <a:srgbClr val="323232"/>
                 </a:solidFill>
@@ -7223,7 +7223,7 @@
               </a:spcAft>
             </a:pPr>
             <a:r>
-              <a:rPr sz="1000" b="0" i="0">
+              <a:rPr sz="1200" b="0" i="0">
                 <a:solidFill>
                   <a:srgbClr val="0F2850"/>
                 </a:solidFill>
@@ -7435,7 +7435,7 @@
               </a:spcAft>
             </a:pPr>
             <a:r>
-              <a:rPr sz="1500" b="0" i="1">
+              <a:rPr sz="1700" b="0" i="1">
                 <a:solidFill>
                   <a:srgbClr val="323232"/>
                 </a:solidFill>
@@ -7523,7 +7523,7 @@
               </a:spcAft>
             </a:pPr>
             <a:r>
-              <a:rPr sz="1300" b="0" i="0">
+              <a:rPr sz="1500" b="0" i="0">
                 <a:solidFill>
                   <a:srgbClr val="323232"/>
                 </a:solidFill>
@@ -7611,7 +7611,7 @@
               </a:spcAft>
             </a:pPr>
             <a:r>
-              <a:rPr sz="1300" b="0" i="0">
+              <a:rPr sz="1500" b="0" i="0">
                 <a:solidFill>
                   <a:srgbClr val="323232"/>
                 </a:solidFill>
@@ -7650,7 +7650,7 @@
               </a:spcAft>
             </a:pPr>
             <a:r>
-              <a:rPr sz="1100" b="0" i="0">
+              <a:rPr sz="1200" b="0" i="0">
                 <a:solidFill>
                   <a:srgbClr val="646464"/>
                 </a:solidFill>

</xml_diff>

<commit_message>
feat: embed live app screenshot in Slide 8, remove old PPT files
</commit_message>
<xml_diff>
--- a/AirSeva_1M1B_Submission_Redesigned.pptx
+++ b/AirSeva_1M1B_Submission_Redesigned.pptx
@@ -6836,7 +6836,7 @@
         <p:spPr>
           <a:xfrm>
             <a:off x="365760" y="1005840"/>
-            <a:ext cx="5394960" cy="4389120"/>
+            <a:ext cx="5029200" cy="4389120"/>
           </a:xfrm>
           <a:prstGeom prst="rect">
             <a:avLst/>
@@ -6997,14 +6997,53 @@
       </p:sp>
       <p:sp>
         <p:nvSpPr>
-          <p:cNvPr id="5" name="Rectangle 4"/>
+          <p:cNvPr id="5" name="TextBox 4"/>
+          <p:cNvSpPr txBox="1"/>
+          <p:nvPr/>
+        </p:nvSpPr>
+        <p:spPr>
+          <a:xfrm>
+            <a:off x="5669280" y="1005840"/>
+            <a:ext cx="6153912" cy="292608"/>
+          </a:xfrm>
+          <a:prstGeom prst="rect">
+            <a:avLst/>
+          </a:prstGeom>
+          <a:noFill/>
+        </p:spPr>
+        <p:txBody>
+          <a:bodyPr wrap="square">
+            <a:spAutoFit/>
+          </a:bodyPr>
+          <a:lstStyle/>
+          <a:p>
+            <a:pPr algn="l">
+              <a:spcAft>
+                <a:spcPts val="400"/>
+              </a:spcAft>
+            </a:pPr>
+            <a:r>
+              <a:rPr sz="1300" b="1" i="0">
+                <a:solidFill>
+                  <a:srgbClr val="0F2850"/>
+                </a:solidFill>
+                <a:latin typeface="Calibri"/>
+              </a:rPr>
+              <a:t>Live App — AirSeva Dashboard</a:t>
+            </a:r>
+          </a:p>
+        </p:txBody>
+      </p:sp>
+      <p:sp>
+        <p:nvSpPr>
+          <p:cNvPr id="6" name="Rectangle 5"/>
           <p:cNvSpPr/>
           <p:nvPr/>
         </p:nvSpPr>
         <p:spPr>
           <a:xfrm>
-            <a:off x="6309360" y="1005840"/>
-            <a:ext cx="5394960" cy="4389120"/>
+            <a:off x="5669280" y="1353312"/>
+            <a:ext cx="6153912" cy="4041648"/>
           </a:xfrm>
           <a:prstGeom prst="rect">
             <a:avLst/>
@@ -7031,180 +7070,47 @@
           </a:fontRef>
         </p:style>
         <p:txBody>
-          <a:bodyPr rtlCol="0" anchor="ctr" wrap="square" lIns="228600" rIns="228600" tIns="228600" bIns="228600"/>
-          <a:lstStyle/>
-          <a:p>
-            <a:pPr algn="l">
-              <a:spcAft>
-                <a:spcPts val="400"/>
-              </a:spcAft>
-            </a:pPr>
-            <a:r>
-              <a:rPr sz="1600" b="1" i="0">
-                <a:solidFill>
-                  <a:srgbClr val="0F2850"/>
-                </a:solidFill>
-                <a:latin typeface="Calibri"/>
-              </a:rPr>
-              <a:t>Key Features</a:t>
-            </a:r>
-          </a:p>
-          <a:p>
-            <a:pPr algn="l">
-              <a:spcAft>
-                <a:spcPts val="200"/>
-              </a:spcAft>
-            </a:pPr>
-            <a:r>
-              <a:rPr sz="600" b="0" i="0">
-                <a:solidFill>
-                  <a:srgbClr val="323232"/>
-                </a:solidFill>
-                <a:latin typeface="Calibri"/>
-              </a:rPr>
-              <a:t/>
-            </a:r>
-          </a:p>
-          <a:p>
-            <a:pPr algn="l">
-              <a:spcAft>
-                <a:spcPts val="500"/>
-              </a:spcAft>
-            </a:pPr>
-            <a:r>
-              <a:rPr sz="1400" b="0" i="0">
-                <a:solidFill>
-                  <a:srgbClr val="323232"/>
-                </a:solidFill>
-                <a:latin typeface="Calibri"/>
-              </a:rPr>
-              <a:t>✔  GPS location detection</a:t>
-            </a:r>
-          </a:p>
-          <a:p>
-            <a:pPr algn="l">
-              <a:spcAft>
-                <a:spcPts val="500"/>
-              </a:spcAft>
-            </a:pPr>
-            <a:r>
-              <a:rPr sz="1400" b="0" i="0">
-                <a:solidFill>
-                  <a:srgbClr val="323232"/>
-                </a:solidFill>
-                <a:latin typeface="Calibri"/>
-              </a:rPr>
-              <a:t>✔  26 Indian cities supported</a:t>
-            </a:r>
-          </a:p>
-          <a:p>
-            <a:pPr algn="l">
-              <a:spcAft>
-                <a:spcPts val="500"/>
-              </a:spcAft>
-            </a:pPr>
-            <a:r>
-              <a:rPr sz="1400" b="0" i="0">
-                <a:solidFill>
-                  <a:srgbClr val="323232"/>
-                </a:solidFill>
-                <a:latin typeface="Calibri"/>
-              </a:rPr>
-              <a:t>✔  WHO 2021 guideline comparison</a:t>
-            </a:r>
-          </a:p>
-          <a:p>
-            <a:pPr algn="l">
-              <a:spcAft>
-                <a:spcPts val="500"/>
-              </a:spcAft>
-            </a:pPr>
-            <a:r>
-              <a:rPr sz="1400" b="0" i="0">
-                <a:solidFill>
-                  <a:srgbClr val="323232"/>
-                </a:solidFill>
-                <a:latin typeface="Calibri"/>
-              </a:rPr>
-              <a:t>✔  Personalised vulnerability score (0–8)</a:t>
-            </a:r>
-          </a:p>
-          <a:p>
-            <a:pPr algn="l">
-              <a:spcAft>
-                <a:spcPts val="500"/>
-              </a:spcAft>
-            </a:pPr>
-            <a:r>
-              <a:rPr sz="1400" b="0" i="0">
-                <a:solidFill>
-                  <a:srgbClr val="323232"/>
-                </a:solidFill>
-                <a:latin typeface="Calibri"/>
-              </a:rPr>
-              <a:t>✔  AQI gauge + pollutant bar chart</a:t>
-            </a:r>
-          </a:p>
-          <a:p>
-            <a:pPr algn="l">
-              <a:spcAft>
-                <a:spcPts val="500"/>
-              </a:spcAft>
-            </a:pPr>
-            <a:r>
-              <a:rPr sz="1400" b="0" i="0">
-                <a:solidFill>
-                  <a:srgbClr val="323232"/>
-                </a:solidFill>
-                <a:latin typeface="Calibri"/>
-              </a:rPr>
-              <a:t>✔  IBM Granite 4 health advisory</a:t>
-            </a:r>
-          </a:p>
-          <a:p>
-            <a:pPr algn="l">
-              <a:spcAft>
-                <a:spcPts val="500"/>
-              </a:spcAft>
-            </a:pPr>
-            <a:r>
-              <a:rPr sz="1400" b="0" i="0">
-                <a:solidFill>
-                  <a:srgbClr val="323232"/>
-                </a:solidFill>
-                <a:latin typeface="Calibri"/>
-              </a:rPr>
-              <a:t>✔  Downloadable PDF report</a:t>
-            </a:r>
-          </a:p>
-          <a:p>
-            <a:pPr algn="l">
-              <a:spcAft>
-                <a:spcPts val="0"/>
-              </a:spcAft>
-            </a:pPr>
-            <a:r>
-              <a:rPr sz="1400" b="0" i="0">
-                <a:solidFill>
-                  <a:srgbClr val="323232"/>
-                </a:solidFill>
-                <a:latin typeface="Calibri"/>
-              </a:rPr>
-              <a:t>✔  Medical disclaimer included</a:t>
-            </a:r>
-          </a:p>
-        </p:txBody>
-      </p:sp>
-      <p:sp>
-        <p:nvSpPr>
-          <p:cNvPr id="6" name="TextBox 5"/>
+          <a:bodyPr rtlCol="0" anchor="ctr"/>
+          <a:lstStyle/>
+          <a:p>
+            <a:pPr algn="ctr"/>
+          </a:p>
+        </p:txBody>
+      </p:sp>
+      <p:pic>
+        <p:nvPicPr>
+          <p:cNvPr id="7" name="Picture 6" descr="airseva_dashboard_1782325407729.png"/>
+          <p:cNvPicPr>
+            <a:picLocks noChangeAspect="1"/>
+          </p:cNvPicPr>
+          <p:nvPr/>
+        </p:nvPicPr>
+        <p:blipFill>
+          <a:blip r:embed="rId2"/>
+          <a:stretch>
+            <a:fillRect/>
+          </a:stretch>
+        </p:blipFill>
+        <p:spPr>
+          <a:xfrm>
+            <a:off x="5715000" y="1399032"/>
+            <a:ext cx="6062472" cy="3950208"/>
+          </a:xfrm>
+          <a:prstGeom prst="rect">
+            <a:avLst/>
+          </a:prstGeom>
+        </p:spPr>
+      </p:pic>
+      <p:sp>
+        <p:nvSpPr>
+          <p:cNvPr id="8" name="TextBox 7"/>
           <p:cNvSpPr txBox="1"/>
           <p:nvPr/>
         </p:nvSpPr>
         <p:spPr>
           <a:xfrm>
-            <a:off x="365760" y="5577840"/>
-            <a:ext cx="11430000" cy="274320"/>
+            <a:off x="365760" y="5532120"/>
+            <a:ext cx="11457432" cy="292608"/>
           </a:xfrm>
           <a:prstGeom prst="rect">
             <a:avLst/>
@@ -7223,6 +7129,45 @@
               </a:spcAft>
             </a:pPr>
             <a:r>
+              <a:rPr sz="1100" b="0" i="0">
+                <a:solidFill>
+                  <a:srgbClr val="323232"/>
+                </a:solidFill>
+                <a:latin typeface="Calibri"/>
+              </a:rPr>
+              <a:t>✔ GPS detection  ·  ✔ 26 cities  ·  ✔ WHO 2021 guidelines  ·  ✔ Vulnerability score (0–8)  ·  ✔ IBM Granite 4 advisory  ·  ✔ Downloadable PDF  ·  ✔ Medical disclaimer</a:t>
+            </a:r>
+          </a:p>
+        </p:txBody>
+      </p:sp>
+      <p:sp>
+        <p:nvSpPr>
+          <p:cNvPr id="9" name="TextBox 8"/>
+          <p:cNvSpPr txBox="1"/>
+          <p:nvPr/>
+        </p:nvSpPr>
+        <p:spPr>
+          <a:xfrm>
+            <a:off x="365760" y="5943600"/>
+            <a:ext cx="11457432" cy="256032"/>
+          </a:xfrm>
+          <a:prstGeom prst="rect">
+            <a:avLst/>
+          </a:prstGeom>
+          <a:noFill/>
+        </p:spPr>
+        <p:txBody>
+          <a:bodyPr wrap="square">
+            <a:spAutoFit/>
+          </a:bodyPr>
+          <a:lstStyle/>
+          <a:p>
+            <a:pPr algn="ctr">
+              <a:spcAft>
+                <a:spcPts val="400"/>
+              </a:spcAft>
+            </a:pPr>
+            <a:r>
               <a:rPr sz="1200" b="0" i="0">
                 <a:solidFill>
                   <a:srgbClr val="0F2850"/>
@@ -7236,7 +7181,7 @@
       </p:sp>
       <p:sp>
         <p:nvSpPr>
-          <p:cNvPr id="7" name="Rectangle 6"/>
+          <p:cNvPr id="10" name="Rectangle 9"/>
           <p:cNvSpPr/>
           <p:nvPr/>
         </p:nvSpPr>

</xml_diff>

<commit_message>
feat: replace Slide 8 text flow with architecture diagram + app screenshot
</commit_message>
<xml_diff>
--- a/AirSeva_1M1B_Submission_Redesigned.pptx
+++ b/AirSeva_1M1B_Submission_Redesigned.pptx
@@ -6829,14 +6829,53 @@
       </p:sp>
       <p:sp>
         <p:nvSpPr>
-          <p:cNvPr id="4" name="Rectangle 3"/>
+          <p:cNvPr id="4" name="TextBox 3"/>
+          <p:cNvSpPr txBox="1"/>
+          <p:nvPr/>
+        </p:nvSpPr>
+        <p:spPr>
+          <a:xfrm>
+            <a:off x="365760" y="1005840"/>
+            <a:ext cx="5486400" cy="292608"/>
+          </a:xfrm>
+          <a:prstGeom prst="rect">
+            <a:avLst/>
+          </a:prstGeom>
+          <a:noFill/>
+        </p:spPr>
+        <p:txBody>
+          <a:bodyPr wrap="square">
+            <a:spAutoFit/>
+          </a:bodyPr>
+          <a:lstStyle/>
+          <a:p>
+            <a:pPr algn="l">
+              <a:spcAft>
+                <a:spcPts val="400"/>
+              </a:spcAft>
+            </a:pPr>
+            <a:r>
+              <a:rPr sz="1300" b="1" i="0">
+                <a:solidFill>
+                  <a:srgbClr val="0F2850"/>
+                </a:solidFill>
+                <a:latin typeface="Calibri"/>
+              </a:rPr>
+              <a:t>System Architecture — 4-Agent Pipeline</a:t>
+            </a:r>
+          </a:p>
+        </p:txBody>
+      </p:sp>
+      <p:sp>
+        <p:nvSpPr>
+          <p:cNvPr id="5" name="Rectangle 4"/>
           <p:cNvSpPr/>
           <p:nvPr/>
         </p:nvSpPr>
         <p:spPr>
           <a:xfrm>
-            <a:off x="365760" y="1005840"/>
-            <a:ext cx="5029200" cy="4389120"/>
+            <a:off x="365760" y="1353312"/>
+            <a:ext cx="5486400" cy="4800600"/>
           </a:xfrm>
           <a:prstGeom prst="rect">
             <a:avLst/>
@@ -6863,213 +6902,6 @@
           </a:fontRef>
         </p:style>
         <p:txBody>
-          <a:bodyPr rtlCol="0" anchor="ctr" wrap="square" lIns="228600" rIns="228600" tIns="228600" bIns="228600"/>
-          <a:lstStyle/>
-          <a:p>
-            <a:pPr algn="l">
-              <a:spcAft>
-                <a:spcPts val="400"/>
-              </a:spcAft>
-            </a:pPr>
-            <a:r>
-              <a:rPr sz="1600" b="1" i="0">
-                <a:solidFill>
-                  <a:srgbClr val="0F2850"/>
-                </a:solidFill>
-                <a:latin typeface="Calibri"/>
-              </a:rPr>
-              <a:t>Agent Flow</a:t>
-            </a:r>
-          </a:p>
-          <a:p>
-            <a:pPr algn="l">
-              <a:spcAft>
-                <a:spcPts val="200"/>
-              </a:spcAft>
-            </a:pPr>
-            <a:r>
-              <a:rPr sz="600" b="0" i="0">
-                <a:solidFill>
-                  <a:srgbClr val="323232"/>
-                </a:solidFill>
-                <a:latin typeface="Calibri"/>
-              </a:rPr>
-              <a:t/>
-            </a:r>
-          </a:p>
-          <a:p>
-            <a:pPr algn="l">
-              <a:spcAft>
-                <a:spcPts val="500"/>
-              </a:spcAft>
-            </a:pPr>
-            <a:r>
-              <a:rPr sz="1400" b="0" i="0">
-                <a:solidFill>
-                  <a:srgbClr val="323232"/>
-                </a:solidFill>
-                <a:latin typeface="Calibri"/>
-              </a:rPr>
-              <a:t>User selects city + health profile</a:t>
-            </a:r>
-          </a:p>
-          <a:p>
-            <a:pPr algn="l">
-              <a:spcAft>
-                <a:spcPts val="500"/>
-              </a:spcAft>
-            </a:pPr>
-            <a:r>
-              <a:rPr sz="1400" b="0" i="0">
-                <a:solidFill>
-                  <a:srgbClr val="323232"/>
-                </a:solidFill>
-                <a:latin typeface="Calibri"/>
-              </a:rPr>
-              <a:t>→  Agent 1: Fetches live AQI + pollutant data</a:t>
-            </a:r>
-          </a:p>
-          <a:p>
-            <a:pPr algn="l">
-              <a:spcAft>
-                <a:spcPts val="500"/>
-              </a:spcAft>
-            </a:pPr>
-            <a:r>
-              <a:rPr sz="1400" b="0" i="0">
-                <a:solidFill>
-                  <a:srgbClr val="323232"/>
-                </a:solidFill>
-                <a:latin typeface="Calibri"/>
-              </a:rPr>
-              <a:t>→  Agent 2: Random Forest predicts risk level</a:t>
-            </a:r>
-          </a:p>
-          <a:p>
-            <a:pPr algn="l">
-              <a:spcAft>
-                <a:spcPts val="500"/>
-              </a:spcAft>
-            </a:pPr>
-            <a:r>
-              <a:rPr sz="1400" b="0" i="0">
-                <a:solidFill>
-                  <a:srgbClr val="323232"/>
-                </a:solidFill>
-                <a:latin typeface="Calibri"/>
-              </a:rPr>
-              <a:t>→  Agent 3: IBM Granite 4 generates advisory</a:t>
-            </a:r>
-          </a:p>
-          <a:p>
-            <a:pPr algn="l">
-              <a:spcAft>
-                <a:spcPts val="500"/>
-              </a:spcAft>
-            </a:pPr>
-            <a:r>
-              <a:rPr sz="1400" b="0" i="0">
-                <a:solidFill>
-                  <a:srgbClr val="323232"/>
-                </a:solidFill>
-                <a:latin typeface="Calibri"/>
-              </a:rPr>
-              <a:t>→  Agent 4: Compiles PDF report</a:t>
-            </a:r>
-          </a:p>
-          <a:p>
-            <a:pPr algn="l">
-              <a:spcAft>
-                <a:spcPts val="0"/>
-              </a:spcAft>
-            </a:pPr>
-            <a:r>
-              <a:rPr sz="1400" b="0" i="0">
-                <a:solidFill>
-                  <a:srgbClr val="323232"/>
-                </a:solidFill>
-                <a:latin typeface="Calibri"/>
-              </a:rPr>
-              <a:t>→  Dashboard displays results + download</a:t>
-            </a:r>
-          </a:p>
-        </p:txBody>
-      </p:sp>
-      <p:sp>
-        <p:nvSpPr>
-          <p:cNvPr id="5" name="TextBox 4"/>
-          <p:cNvSpPr txBox="1"/>
-          <p:nvPr/>
-        </p:nvSpPr>
-        <p:spPr>
-          <a:xfrm>
-            <a:off x="5669280" y="1005840"/>
-            <a:ext cx="6153912" cy="292608"/>
-          </a:xfrm>
-          <a:prstGeom prst="rect">
-            <a:avLst/>
-          </a:prstGeom>
-          <a:noFill/>
-        </p:spPr>
-        <p:txBody>
-          <a:bodyPr wrap="square">
-            <a:spAutoFit/>
-          </a:bodyPr>
-          <a:lstStyle/>
-          <a:p>
-            <a:pPr algn="l">
-              <a:spcAft>
-                <a:spcPts val="400"/>
-              </a:spcAft>
-            </a:pPr>
-            <a:r>
-              <a:rPr sz="1300" b="1" i="0">
-                <a:solidFill>
-                  <a:srgbClr val="0F2850"/>
-                </a:solidFill>
-                <a:latin typeface="Calibri"/>
-              </a:rPr>
-              <a:t>Live App — AirSeva Dashboard</a:t>
-            </a:r>
-          </a:p>
-        </p:txBody>
-      </p:sp>
-      <p:sp>
-        <p:nvSpPr>
-          <p:cNvPr id="6" name="Rectangle 5"/>
-          <p:cNvSpPr/>
-          <p:nvPr/>
-        </p:nvSpPr>
-        <p:spPr>
-          <a:xfrm>
-            <a:off x="5669280" y="1353312"/>
-            <a:ext cx="6153912" cy="4041648"/>
-          </a:xfrm>
-          <a:prstGeom prst="rect">
-            <a:avLst/>
-          </a:prstGeom>
-          <a:solidFill>
-            <a:srgbClr val="F0F5FC"/>
-          </a:solidFill>
-          <a:ln>
-            <a:noFill/>
-          </a:ln>
-        </p:spPr>
-        <p:style>
-          <a:lnRef idx="1">
-            <a:schemeClr val="accent1"/>
-          </a:lnRef>
-          <a:fillRef idx="3">
-            <a:schemeClr val="accent1"/>
-          </a:fillRef>
-          <a:effectRef idx="2">
-            <a:schemeClr val="accent1"/>
-          </a:effectRef>
-          <a:fontRef idx="minor">
-            <a:schemeClr val="lt1"/>
-          </a:fontRef>
-        </p:style>
-        <p:txBody>
           <a:bodyPr rtlCol="0" anchor="ctr"/>
           <a:lstStyle/>
           <a:p>
@@ -7079,7 +6911,7 @@
       </p:sp>
       <p:pic>
         <p:nvPicPr>
-          <p:cNvPr id="7" name="Picture 6" descr="airseva_dashboard_1782325407729.png"/>
+          <p:cNvPr id="6" name="Picture 5" descr="architecture_diagram.png"/>
           <p:cNvPicPr>
             <a:picLocks noChangeAspect="1"/>
           </p:cNvPicPr>
@@ -7093,8 +6925,8 @@
         </p:blipFill>
         <p:spPr>
           <a:xfrm>
-            <a:off x="5715000" y="1399032"/>
-            <a:ext cx="6062472" cy="3950208"/>
+            <a:off x="411480" y="1399032"/>
+            <a:ext cx="5394960" cy="4709160"/>
           </a:xfrm>
           <a:prstGeom prst="rect">
             <a:avLst/>
@@ -7103,14 +6935,14 @@
       </p:pic>
       <p:sp>
         <p:nvSpPr>
-          <p:cNvPr id="8" name="TextBox 7"/>
+          <p:cNvPr id="7" name="TextBox 6"/>
           <p:cNvSpPr txBox="1"/>
           <p:nvPr/>
         </p:nvSpPr>
         <p:spPr>
           <a:xfrm>
-            <a:off x="365760" y="5532120"/>
-            <a:ext cx="11457432" cy="292608"/>
+            <a:off x="6126480" y="1005840"/>
+            <a:ext cx="5696712" cy="292608"/>
           </a:xfrm>
           <a:prstGeom prst="rect">
             <a:avLst/>
@@ -7123,32 +6955,99 @@
           </a:bodyPr>
           <a:lstStyle/>
           <a:p>
-            <a:pPr algn="ctr">
+            <a:pPr algn="l">
               <a:spcAft>
                 <a:spcPts val="400"/>
               </a:spcAft>
             </a:pPr>
             <a:r>
-              <a:rPr sz="1100" b="0" i="0">
-                <a:solidFill>
-                  <a:srgbClr val="323232"/>
-                </a:solidFill>
-                <a:latin typeface="Calibri"/>
-              </a:rPr>
-              <a:t>✔ GPS detection  ·  ✔ 26 cities  ·  ✔ WHO 2021 guidelines  ·  ✔ Vulnerability score (0–8)  ·  ✔ IBM Granite 4 advisory  ·  ✔ Downloadable PDF  ·  ✔ Medical disclaimer</a:t>
-            </a:r>
-          </a:p>
-        </p:txBody>
-      </p:sp>
-      <p:sp>
-        <p:nvSpPr>
-          <p:cNvPr id="9" name="TextBox 8"/>
+              <a:rPr sz="1300" b="1" i="0">
+                <a:solidFill>
+                  <a:srgbClr val="0F2850"/>
+                </a:solidFill>
+                <a:latin typeface="Calibri"/>
+              </a:rPr>
+              <a:t>Live App — AirSeva Dashboard</a:t>
+            </a:r>
+          </a:p>
+        </p:txBody>
+      </p:sp>
+      <p:sp>
+        <p:nvSpPr>
+          <p:cNvPr id="8" name="Rectangle 7"/>
+          <p:cNvSpPr/>
+          <p:nvPr/>
+        </p:nvSpPr>
+        <p:spPr>
+          <a:xfrm>
+            <a:off x="6126480" y="1353312"/>
+            <a:ext cx="5696712" cy="4800600"/>
+          </a:xfrm>
+          <a:prstGeom prst="rect">
+            <a:avLst/>
+          </a:prstGeom>
+          <a:solidFill>
+            <a:srgbClr val="F0F5FC"/>
+          </a:solidFill>
+          <a:ln>
+            <a:noFill/>
+          </a:ln>
+        </p:spPr>
+        <p:style>
+          <a:lnRef idx="1">
+            <a:schemeClr val="accent1"/>
+          </a:lnRef>
+          <a:fillRef idx="3">
+            <a:schemeClr val="accent1"/>
+          </a:fillRef>
+          <a:effectRef idx="2">
+            <a:schemeClr val="accent1"/>
+          </a:effectRef>
+          <a:fontRef idx="minor">
+            <a:schemeClr val="lt1"/>
+          </a:fontRef>
+        </p:style>
+        <p:txBody>
+          <a:bodyPr rtlCol="0" anchor="ctr"/>
+          <a:lstStyle/>
+          <a:p>
+            <a:pPr algn="ctr"/>
+          </a:p>
+        </p:txBody>
+      </p:sp>
+      <p:pic>
+        <p:nvPicPr>
+          <p:cNvPr id="9" name="Picture 8" descr="airseva_dashboard_1782325407729.png"/>
+          <p:cNvPicPr>
+            <a:picLocks noChangeAspect="1"/>
+          </p:cNvPicPr>
+          <p:nvPr/>
+        </p:nvPicPr>
+        <p:blipFill>
+          <a:blip r:embed="rId3"/>
+          <a:stretch>
+            <a:fillRect/>
+          </a:stretch>
+        </p:blipFill>
+        <p:spPr>
+          <a:xfrm>
+            <a:off x="6172200" y="1399032"/>
+            <a:ext cx="5605272" cy="4709160"/>
+          </a:xfrm>
+          <a:prstGeom prst="rect">
+            <a:avLst/>
+          </a:prstGeom>
+        </p:spPr>
+      </p:pic>
+      <p:sp>
+        <p:nvSpPr>
+          <p:cNvPr id="10" name="TextBox 9"/>
           <p:cNvSpPr txBox="1"/>
           <p:nvPr/>
         </p:nvSpPr>
         <p:spPr>
           <a:xfrm>
-            <a:off x="365760" y="5943600"/>
+            <a:off x="365760" y="6291072"/>
             <a:ext cx="11457432" cy="256032"/>
           </a:xfrm>
           <a:prstGeom prst="rect">
@@ -7181,7 +7080,7 @@
       </p:sp>
       <p:sp>
         <p:nvSpPr>
-          <p:cNvPr id="10" name="Rectangle 9"/>
+          <p:cNvPr id="11" name="Rectangle 10"/>
           <p:cNvSpPr/>
           <p:nvPr/>
         </p:nvSpPr>

</xml_diff>